<commit_message>
Briefing deck: slide 16 shows the fixed loop cards
Re-cropped img/loops.png from the re-rendered Loops/_Demo.png, so the
mode chip shows as a pill (AUTO gray, MAN dark, CAS light blue) at the
right of the header. Corrected the third bullet: the orange diamond
and outline mean a deviation alarm, not a non-normal mode; it now
describes the mode chip. Speaker notes for slide 16 updated to match.
Deck rebuilt with build_deck.js and the EFC theme; only slide 16, its
notes and its image changed.

Co-Authored-By: Claude Opus 5.5 <noreply@anthropic.com>
Claude-Session: https://claude.ai/code/session_01TX3d47kQpcenHPBKHJvmBr
</commit_message>
<xml_diff>
--- a/docs/presentations/EFCLib_v1_Engineering_Briefing.pptx
+++ b/docs/presentations/EFCLib_v1_Engineering_Briefing.pptx
@@ -132,7 +132,7 @@
   <p:extLst>
     <p:ext uri="{521415D9-36F7-43E2-AB2F-B90AF26B5E84}">
       <p14:sectionLst xmlns:p14="http://schemas.microsoft.com/office/powerpoint/2010/main">
-        <p14:section name="Introduction" id="{b43e366f-cf8d-91f7-577e-50bb47fb268b}">
+        <p14:section name="Introduction" id="{804fccea-f9a1-44b5-9d57-30bef48b067f}">
           <p14:sldIdLst>
             <p14:sldId id="256"/>
             <p14:sldId id="257"/>
@@ -140,14 +140,14 @@
             <p14:sldId id="259"/>
           </p14:sldIdLst>
         </p14:section>
-        <p14:section name="Styles" id="{4f364028-abc0-d643-e25c-8178b879ef5d}">
+        <p14:section name="Styles" id="{b00d77d5-f8f9-6c56-91a3-f4c2ddc24e75}">
           <p14:sldIdLst>
             <p14:sldId id="260"/>
             <p14:sldId id="261"/>
             <p14:sldId id="262"/>
           </p14:sldIdLst>
         </p14:section>
-        <p14:section name="Symbols and device templates" id="{e8af3c10-02ca-f456-7dc1-f545b5015068}">
+        <p14:section name="Symbols and device templates" id="{7e148d32-41f3-4e0a-e56e-72476f69cae3}">
           <p14:sldIdLst>
             <p14:sldId id="263"/>
             <p14:sldId id="264"/>
@@ -157,14 +157,14 @@
             <p14:sldId id="268"/>
           </p14:sldIdLst>
         </p14:section>
-        <p14:section name="Values, indicators and loops" id="{4fa0c3aa-e479-ff75-f8c5-4663ebc91843}">
+        <p14:section name="Values, indicators and loops" id="{a6093ad6-3a76-1d90-8656-13a9731dcd26}">
           <p14:sldIdLst>
             <p14:sldId id="269"/>
             <p14:sldId id="270"/>
             <p14:sldId id="271"/>
           </p14:sldIdLst>
         </p14:section>
-        <p14:section name="Dynamic windows" id="{c1c67ced-6de8-7b59-ae66-213ccd057d84}">
+        <p14:section name="Dynamic windows" id="{2b2094b3-61d0-0cbd-9cab-4296b927b182}">
           <p14:sldIdLst>
             <p14:sldId id="272"/>
             <p14:sldId id="273"/>
@@ -175,7 +175,7 @@
             <p14:sldId id="278"/>
           </p14:sldIdLst>
         </p14:section>
-        <p14:section name="Wrap-up" id="{ce040bbc-d524-4a26-c0f2-5307070e4921}">
+        <p14:section name="Wrap-up" id="{c5eb4395-dd2f-2acb-b133-b224d798e5bb}">
           <p14:sldIdLst>
             <p14:sldId id="279"/>
             <p14:sldId id="280"/>
@@ -1306,6 +1306,8 @@
 KEY POINTS:
 - B1: vertical bar with an SP pointer and alarm ticks. B2: horizontal bar with a normal band between the low and high alarm limits. B3: sparkline with a one-minute PV and SP trace and a deviation chip that turns orange past the deviation alarm. B4: twin columns for PV and OUT.
 - Setpoint is blue because it is editable (palette).
+- Mode chip: a pill at the right end of the header (B4: its own row under the tag). AUTO is light gray with gray text, MAN is dark with white text because Manual is the abnormal mode, CAS is light blue with blue text. This matches the option B mockup.
+- The orange diamond beside the tag and the orange card outline mean a deviation alarm is active (high or low). They do not show the mode.
 - The whole card calls efc.ui.openDynamic, which opens dw_Loop.
 - The LoopConfig popup is retired (decision 15). Tuning and limits are in dw_Loop, with tuning collapsed and editable at Engineer or higher.
 - In dw_Loop, MAN, AUTO and CAS buttons are at Operator; the setpoint is locked in CAS; the output is editable only in MAN.
@@ -10166,7 +10168,7 @@
                   <a:schemeClr val="tx1"/>
                 </a:solidFill>
               </a:rPr>
-              <a:t>Orange diamond = loop not in its normal mode (e.g. MAN)</a:t>
+              <a:t>Mode chip, right of the tag: AUTO light gray, MAN dark (abnormal), CAS light blue. Orange diamond and outline = deviation alarm</a:t>
             </a:r>
             <a:endParaRPr lang="en-US" sz="1400" dirty="0"/>
           </a:p>

</xml_diff>